<commit_message>
add zero shot ppl obv
</commit_message>
<xml_diff>
--- a/doc/mtp with consistency method.pptx
+++ b/doc/mtp with consistency method.pptx
@@ -238,7 +238,7 @@
           <a:p>
             <a:fld id="{D392C71C-3914-42D5-B995-B912727F46CE}" type="datetimeFigureOut">
               <a:rPr lang="zh-TW" altLang="en-US" smtClean="0"/>
-              <a:t>2026/7/9</a:t>
+              <a:t>2026/7/13</a:t>
             </a:fld>
             <a:endParaRPr lang="zh-TW" altLang="en-US"/>
           </a:p>
@@ -415,7 +415,7 @@
           <a:p>
             <a:fld id="{01EF2EC2-8746-4753-8458-2ED9A5172172}" type="datetimeFigureOut">
               <a:rPr lang="zh-TW" altLang="en-US" smtClean="0"/>
-              <a:t>2026/7/9</a:t>
+              <a:t>2026/7/13</a:t>
             </a:fld>
             <a:endParaRPr lang="zh-TW" altLang="en-US"/>
           </a:p>
@@ -19304,8 +19304,8 @@
             </p:sp>
           </mc:Fallback>
         </mc:AlternateContent>
-        <mc:AlternateContent xmlns:mc="http://schemas.openxmlformats.org/markup-compatibility/2006">
-          <mc:Choice xmlns:a14="http://schemas.microsoft.com/office/drawing/2010/main" Requires="a14">
+        <mc:AlternateContent xmlns:mc="http://schemas.openxmlformats.org/markup-compatibility/2006" xmlns:a14="http://schemas.microsoft.com/office/drawing/2010/main">
+          <mc:Choice Requires="a14">
             <p:sp>
               <p:nvSpPr>
                 <p:cNvPr id="26" name="文字方塊 25">
@@ -19503,7 +19503,7 @@
               </p:txBody>
             </p:sp>
           </mc:Choice>
-          <mc:Fallback>
+          <mc:Fallback xmlns="">
             <p:sp>
               <p:nvSpPr>
                 <p:cNvPr id="26" name="文字方塊 25">
@@ -24556,7 +24556,7 @@
                     <a:ea typeface="微軟正黑體" panose="020B0604030504040204" pitchFamily="34" charset="-120"/>
                     <a:cs typeface="Noto Sans CJK TC" pitchFamily="34" charset="-120"/>
                   </a:rPr>
-                  <a:t>Page 3 ~ Page 8</a:t>
+                  <a:t>Page 4 ~ Page 7</a:t>
                 </a:r>
                 <a:endParaRPr lang="en-US" sz="1400" dirty="0">
                   <a:latin typeface="微軟正黑體" panose="020B0604030504040204" pitchFamily="34" charset="-120"/>
@@ -24732,7 +24732,7 @@
                     <a:ea typeface="微軟正黑體" panose="020B0604030504040204" pitchFamily="34" charset="-120"/>
                     <a:cs typeface="Noto Sans CJK TC" pitchFamily="34" charset="-120"/>
                   </a:rPr>
-                  <a:t>Page 9 ~ Page 13</a:t>
+                  <a:t>Page 9 ~ Page 11</a:t>
                 </a:r>
                 <a:endParaRPr lang="en-US" sz="1400" dirty="0">
                   <a:latin typeface="微軟正黑體" panose="020B0604030504040204" pitchFamily="34" charset="-120"/>
@@ -24908,7 +24908,7 @@
                     <a:ea typeface="微軟正黑體" panose="020B0604030504040204" pitchFamily="34" charset="-120"/>
                     <a:cs typeface="Noto Sans CJK TC" pitchFamily="34" charset="-120"/>
                   </a:rPr>
-                  <a:t>Page 14 ~ Page 21</a:t>
+                  <a:t>Page 13 ~ Page 15</a:t>
                 </a:r>
                 <a:endParaRPr lang="en-US" sz="1400" dirty="0">
                   <a:latin typeface="微軟正黑體" panose="020B0604030504040204" pitchFamily="34" charset="-120"/>
@@ -25084,7 +25084,7 @@
                     <a:ea typeface="微軟正黑體" panose="020B0604030504040204" pitchFamily="34" charset="-120"/>
                     <a:cs typeface="Noto Sans CJK TC" pitchFamily="34" charset="-120"/>
                   </a:rPr>
-                  <a:t>Page 22 ~ Page 31</a:t>
+                  <a:t>Page 17 ~ Page 24</a:t>
                 </a:r>
                 <a:endParaRPr lang="en-US" sz="1400" dirty="0">
                   <a:latin typeface="微軟正黑體" panose="020B0604030504040204" pitchFamily="34" charset="-120"/>
@@ -25260,7 +25260,7 @@
                     <a:ea typeface="微軟正黑體" panose="020B0604030504040204" pitchFamily="34" charset="-120"/>
                     <a:cs typeface="Noto Sans CJK TC" pitchFamily="34" charset="-120"/>
                   </a:rPr>
-                  <a:t>Page 32 ~ Page 34</a:t>
+                  <a:t>Page 26 ~ Page 27</a:t>
                 </a:r>
                 <a:endParaRPr lang="en-US" sz="1400" dirty="0">
                   <a:latin typeface="微軟正黑體" panose="020B0604030504040204" pitchFamily="34" charset="-120"/>
@@ -26230,7 +26230,7 @@
           <p:nvPr>
             <p:extLst>
               <p:ext uri="{D42A27DB-BD31-4B8C-83A1-F6EECF244321}">
-                <p14:modId xmlns:p14="http://schemas.microsoft.com/office/powerpoint/2010/main" val="2949501019"/>
+                <p14:modId xmlns:p14="http://schemas.microsoft.com/office/powerpoint/2010/main" val="3952725280"/>
               </p:ext>
             </p:extLst>
           </p:nvPr>
@@ -26475,7 +26475,11 @@
                     <a:lstStyle/>
                     <a:p>
                       <a:pPr algn="ctr"/>
-                      <a:endParaRPr lang="zh-TW" altLang="en-US" dirty="0"/>
+                      <a:r>
+                        <a:rPr lang="en-US" altLang="zh-TW" sz="1600" dirty="0"/>
+                        <a:t>consistency mainly improves distant draft prediction.</a:t>
+                      </a:r>
+                      <a:endParaRPr lang="zh-TW" altLang="en-US" sz="1600" dirty="0"/>
                     </a:p>
                   </a:txBody>
                   <a:tcPr anchor="ctr"/>
@@ -26563,7 +26567,11 @@
                     <a:lstStyle/>
                     <a:p>
                       <a:pPr algn="ctr"/>
-                      <a:endParaRPr lang="zh-TW" altLang="en-US" dirty="0"/>
+                      <a:r>
+                        <a:rPr lang="en-US" altLang="zh-TW" sz="1600" dirty="0"/>
+                        <a:t>regular syntax leads to gains across all heads.</a:t>
+                      </a:r>
+                      <a:endParaRPr lang="zh-TW" altLang="en-US" sz="1600" dirty="0"/>
                     </a:p>
                   </a:txBody>
                   <a:tcPr anchor="ctr"/>
@@ -26651,8 +26659,27 @@
                     <a:bodyPr/>
                     <a:lstStyle/>
                     <a:p>
-                      <a:pPr algn="ctr"/>
-                      <a:endParaRPr lang="zh-TW" altLang="en-US" dirty="0"/>
+                      <a:pPr marL="0" marR="0" lvl="0" indent="0" algn="ctr" defTabSz="914400" rtl="0" eaLnBrk="1" fontAlgn="auto" latinLnBrk="0" hangingPunct="1">
+                        <a:lnSpc>
+                          <a:spcPct val="100000"/>
+                        </a:lnSpc>
+                        <a:spcBef>
+                          <a:spcPts val="0"/>
+                        </a:spcBef>
+                        <a:spcAft>
+                          <a:spcPts val="0"/>
+                        </a:spcAft>
+                        <a:buClrTx/>
+                        <a:buSzTx/>
+                        <a:buFontTx/>
+                        <a:buNone/>
+                        <a:tabLst/>
+                        <a:defRPr/>
+                      </a:pPr>
+                      <a:r>
+                        <a:rPr lang="en-US" altLang="zh-TW" sz="1600" dirty="0"/>
+                        <a:t>strong context dependence produces the largest Head 1 gain.</a:t>
+                      </a:r>
                     </a:p>
                   </a:txBody>
                   <a:tcPr anchor="ctr"/>
@@ -26741,7 +26768,11 @@
                     <a:lstStyle/>
                     <a:p>
                       <a:pPr algn="ctr"/>
-                      <a:endParaRPr lang="zh-TW" altLang="en-US" dirty="0"/>
+                      <a:r>
+                        <a:rPr lang="en-US" altLang="zh-TW" sz="1600" dirty="0"/>
+                        <a:t>domain-specific knowledge limits improvement.</a:t>
+                      </a:r>
+                      <a:endParaRPr lang="zh-TW" altLang="en-US" sz="1600" dirty="0"/>
                     </a:p>
                   </a:txBody>
                   <a:tcPr anchor="ctr"/>
@@ -26830,7 +26861,11 @@
                     <a:lstStyle/>
                     <a:p>
                       <a:pPr algn="ctr"/>
-                      <a:endParaRPr lang="zh-TW" altLang="en-US" dirty="0"/>
+                      <a:r>
+                        <a:rPr lang="en-US" altLang="zh-TW" sz="1600" dirty="0"/>
+                        <a:t>structured biomedical writing provides stable gains across heads.</a:t>
+                      </a:r>
+                      <a:endParaRPr lang="zh-TW" altLang="en-US" sz="1600" dirty="0"/>
                     </a:p>
                   </a:txBody>
                   <a:tcPr anchor="ctr"/>

</xml_diff>